<commit_message>
chore: heartbeat git sync — add new skills, update gitignore
</commit_message>
<xml_diff>
--- a/pptxgenjs-editable-template/output/attention_is_all_you_need_dgist-report.pptx
+++ b/pptxgenjs-editable-template/output/attention_is_all_you_need_dgist-report.pptx
@@ -1233,32 +1233,7 @@
       </p:grpSpPr>
       <p:sp>
         <p:nvSpPr>
-          <p:cNvPr id="2" name="Shape 0"/>
-          <p:cNvSpPr/>
-          <p:nvPr/>
-        </p:nvSpPr>
-        <p:spPr>
-          <a:xfrm>
-            <a:off x="0" y="0"/>
-            <a:ext cx="12188952" cy="256032"/>
-          </a:xfrm>
-          <a:prstGeom prst="rect">
-            <a:avLst/>
-          </a:prstGeom>
-          <a:solidFill>
-            <a:srgbClr val="1A3C8C"/>
-          </a:solidFill>
-          <a:ln w="12700">
-            <a:solidFill>
-              <a:srgbClr val="1A3C8C"/>
-            </a:solidFill>
-            <a:prstDash val="solid"/>
-          </a:ln>
-        </p:spPr>
-      </p:sp>
-      <p:sp>
-        <p:nvSpPr>
-          <p:cNvPr id="3" name="Text 1"/>
+          <p:cNvPr id="2" name="Text 0"/>
           <p:cNvSpPr/>
           <p:nvPr/>
         </p:nvSpPr>
@@ -1297,13 +1272,13 @@
       </p:sp>
       <p:sp>
         <p:nvSpPr>
-          <p:cNvPr id="4" name="Shape 2"/>
-          <p:cNvSpPr/>
-          <p:nvPr/>
-        </p:nvSpPr>
-        <p:spPr>
-          <a:xfrm>
-            <a:off x="1737360" y="1234440"/>
+          <p:cNvPr id="3" name="Shape 1"/>
+          <p:cNvSpPr/>
+          <p:nvPr/>
+        </p:nvSpPr>
+        <p:spPr>
+          <a:xfrm>
+            <a:off x="1737360" y="1645920"/>
             <a:ext cx="8686800" cy="2148840"/>
           </a:xfrm>
           <a:prstGeom prst="roundRect">
@@ -1326,13 +1301,13 @@
       </p:sp>
       <p:sp>
         <p:nvSpPr>
-          <p:cNvPr id="5" name="Text 3"/>
-          <p:cNvSpPr/>
-          <p:nvPr/>
-        </p:nvSpPr>
-        <p:spPr>
-          <a:xfrm>
-            <a:off x="2011680" y="1600200"/>
+          <p:cNvPr id="4" name="Text 2"/>
+          <p:cNvSpPr/>
+          <p:nvPr/>
+        </p:nvSpPr>
+        <p:spPr>
+          <a:xfrm>
+            <a:off x="2011680" y="2011680"/>
             <a:ext cx="8138160" cy="731520"/>
           </a:xfrm>
           <a:prstGeom prst="rect">
@@ -1365,13 +1340,13 @@
       </p:sp>
       <p:sp>
         <p:nvSpPr>
-          <p:cNvPr id="6" name="Text 4"/>
-          <p:cNvSpPr/>
-          <p:nvPr/>
-        </p:nvSpPr>
-        <p:spPr>
-          <a:xfrm>
-            <a:off x="2011680" y="2331720"/>
+          <p:cNvPr id="5" name="Text 3"/>
+          <p:cNvSpPr/>
+          <p:nvPr/>
+        </p:nvSpPr>
+        <p:spPr>
+          <a:xfrm>
+            <a:off x="2011680" y="2743200"/>
             <a:ext cx="8138160" cy="320040"/>
           </a:xfrm>
           <a:prstGeom prst="rect">
@@ -1404,7 +1379,7 @@
       </p:sp>
       <p:sp>
         <p:nvSpPr>
-          <p:cNvPr id="7" name="Text 5"/>
+          <p:cNvPr id="6" name="Text 4"/>
           <p:cNvSpPr/>
           <p:nvPr/>
         </p:nvSpPr>
@@ -1443,7 +1418,7 @@
       </p:sp>
       <p:sp>
         <p:nvSpPr>
-          <p:cNvPr id="8" name="Text 6"/>
+          <p:cNvPr id="7" name="Text 5"/>
           <p:cNvSpPr/>
           <p:nvPr/>
         </p:nvSpPr>
@@ -1513,123 +1488,6 @@
               <a:t>소속: DGIST</a:t>
             </a:r>
             <a:endParaRPr lang="en-US" sz="1300" dirty="0"/>
-          </a:p>
-        </p:txBody>
-      </p:sp>
-      <p:sp>
-        <p:nvSpPr>
-          <p:cNvPr id="9" name="Text 7"/>
-          <p:cNvSpPr/>
-          <p:nvPr/>
-        </p:nvSpPr>
-        <p:spPr>
-          <a:xfrm>
-            <a:off x="10058400" y="45720"/>
-            <a:ext cx="2011680" cy="164592"/>
-          </a:xfrm>
-          <a:prstGeom prst="rect">
-            <a:avLst/>
-          </a:prstGeom>
-          <a:noFill/>
-          <a:ln/>
-        </p:spPr>
-        <p:txBody>
-          <a:bodyPr wrap="square" rtlCol="0" anchor="ctr"/>
-          <a:lstStyle/>
-          <a:p>
-            <a:pPr algn="r" indent="0" marL="0">
-              <a:buNone/>
-            </a:pPr>
-            <a:r>
-              <a:rPr lang="en-US" sz="900" b="1" dirty="0">
-                <a:solidFill>
-                  <a:srgbClr val="DCE6FA"/>
-                </a:solidFill>
-                <a:latin typeface="Arial" pitchFamily="34" charset="0"/>
-                <a:ea typeface="Arial" pitchFamily="34" charset="-122"/>
-                <a:cs typeface="Arial" pitchFamily="34" charset="-120"/>
-              </a:rPr>
-              <a:t>2026-04-01</a:t>
-            </a:r>
-            <a:endParaRPr lang="en-US" sz="900" dirty="0"/>
-          </a:p>
-        </p:txBody>
-      </p:sp>
-      <p:sp>
-        <p:nvSpPr>
-          <p:cNvPr id="10" name="Text 8"/>
-          <p:cNvSpPr/>
-          <p:nvPr/>
-        </p:nvSpPr>
-        <p:spPr>
-          <a:xfrm>
-            <a:off x="274320" y="6583680"/>
-            <a:ext cx="3474720" cy="182880"/>
-          </a:xfrm>
-          <a:prstGeom prst="rect">
-            <a:avLst/>
-          </a:prstGeom>
-          <a:noFill/>
-          <a:ln/>
-        </p:spPr>
-        <p:txBody>
-          <a:bodyPr wrap="square" rtlCol="0" anchor="ctr"/>
-          <a:lstStyle/>
-          <a:p>
-            <a:pPr indent="0" marL="0">
-              <a:buNone/>
-            </a:pPr>
-            <a:r>
-              <a:rPr lang="en-US" sz="900" dirty="0">
-                <a:solidFill>
-                  <a:srgbClr val="DCE6FA"/>
-                </a:solidFill>
-                <a:latin typeface="Arial" pitchFamily="34" charset="0"/>
-                <a:ea typeface="Arial" pitchFamily="34" charset="-122"/>
-                <a:cs typeface="Arial" pitchFamily="34" charset="-120"/>
-              </a:rPr>
-              <a:t>Jaeyeong CHOI</a:t>
-            </a:r>
-            <a:endParaRPr lang="en-US" sz="900" dirty="0"/>
-          </a:p>
-        </p:txBody>
-      </p:sp>
-      <p:sp>
-        <p:nvSpPr>
-          <p:cNvPr id="11" name="Text 9"/>
-          <p:cNvSpPr/>
-          <p:nvPr/>
-        </p:nvSpPr>
-        <p:spPr>
-          <a:xfrm>
-            <a:off x="7315200" y="6583680"/>
-            <a:ext cx="4572000" cy="182880"/>
-          </a:xfrm>
-          <a:prstGeom prst="rect">
-            <a:avLst/>
-          </a:prstGeom>
-          <a:noFill/>
-          <a:ln/>
-        </p:spPr>
-        <p:txBody>
-          <a:bodyPr wrap="square" rtlCol="0" anchor="ctr"/>
-          <a:lstStyle/>
-          <a:p>
-            <a:pPr algn="r" indent="0" marL="0">
-              <a:buNone/>
-            </a:pPr>
-            <a:r>
-              <a:rPr lang="en-US" sz="900" dirty="0">
-                <a:solidFill>
-                  <a:srgbClr val="DCE6FA"/>
-                </a:solidFill>
-                <a:latin typeface="Arial" pitchFamily="34" charset="0"/>
-                <a:ea typeface="Arial" pitchFamily="34" charset="-122"/>
-                <a:cs typeface="Arial" pitchFamily="34" charset="-120"/>
-              </a:rPr>
-              <a:t>Attention Is All You Need Presentation</a:t>
-            </a:r>
-            <a:endParaRPr lang="en-US" sz="900" dirty="0"/>
           </a:p>
         </p:txBody>
       </p:sp>
@@ -1884,7 +1742,7 @@
             <a:r>
               <a:rPr lang="en-US" sz="900" b="1" dirty="0">
                 <a:solidFill>
-                  <a:srgbClr val="62709A"/>
+                  <a:srgbClr val="FFFFFF"/>
                 </a:solidFill>
                 <a:latin typeface="Arial" pitchFamily="34" charset="0"/>
                 <a:ea typeface="Arial" pitchFamily="34" charset="-122"/>
@@ -2509,7 +2367,7 @@
             <a:r>
               <a:rPr lang="en-US" sz="900" b="1" dirty="0">
                 <a:solidFill>
-                  <a:srgbClr val="62709A"/>
+                  <a:srgbClr val="FFFFFF"/>
                 </a:solidFill>
                 <a:latin typeface="Arial" pitchFamily="34" charset="0"/>
                 <a:ea typeface="Arial" pitchFamily="34" charset="-122"/>
@@ -3031,7 +2889,7 @@
             <a:r>
               <a:rPr lang="en-US" sz="900" b="1" dirty="0">
                 <a:solidFill>
-                  <a:srgbClr val="62709A"/>
+                  <a:srgbClr val="FFFFFF"/>
                 </a:solidFill>
                 <a:latin typeface="Arial" pitchFamily="34" charset="0"/>
                 <a:ea typeface="Arial" pitchFamily="34" charset="-122"/>
@@ -4084,7 +3942,7 @@
             <a:r>
               <a:rPr lang="en-US" sz="900" b="1" dirty="0">
                 <a:solidFill>
-                  <a:srgbClr val="62709A"/>
+                  <a:srgbClr val="FFFFFF"/>
                 </a:solidFill>
                 <a:latin typeface="Arial" pitchFamily="34" charset="0"/>
                 <a:ea typeface="Arial" pitchFamily="34" charset="-122"/>

</xml_diff>